<commit_message>
Regenerate PPTX for better compatibility
Co-authored-by: siya7205 <177651382+siya7205@users.noreply.github.com>
</commit_message>
<xml_diff>
--- a/Ensemble_Anomaly_Maps_Presentation.pptx
+++ b/Ensemble_Anomaly_Maps_Presentation.pptx
@@ -4365,7 +4365,7 @@
               <a:defRPr sz="1800"/>
             </a:pPr>
             <a:r>
-              <a:t>• Commit: 0c30c17f7a84</a:t>
+              <a:t>• Commit: 7137f94e341c</a:t>
             </a:r>
           </a:p>
           <a:p>
@@ -8181,18 +8181,18 @@
               <a:defRPr sz="1800"/>
             </a:pPr>
             <a:r>
-              <a:t>• Git commit: 0c30c17f7a84</a:t>
-            </a:r>
-          </a:p>
-          <a:p>
-            <a:pPr>
-              <a:spcAft>
-                <a:spcPts val="1200"/>
-              </a:spcAft>
-              <a:defRPr sz="1800"/>
-            </a:pPr>
-            <a:r>
-              <a:t>• Generation date: 2025-11-30 08:55:55</a:t>
+              <a:t>• Git commit: 7137f94e341c</a:t>
+            </a:r>
+          </a:p>
+          <a:p>
+            <a:pPr>
+              <a:spcAft>
+                <a:spcPts val="1200"/>
+              </a:spcAft>
+              <a:defRPr sz="1800"/>
+            </a:pPr>
+            <a:r>
+              <a:t>• Generation date: 2025-11-30 09:06:25</a:t>
             </a:r>
           </a:p>
           <a:p>

</xml_diff>